<commit_message>
Add precipitation example and switch slide figures to colorblind-safe colors
Adds a domain-mean pr seasonal-cycle figure/slide (honest result: raw
already tracks ERA5 reasonably well over this short window, and the
correction slightly overshoots, RMSE 0.27->0.37 mm/day) as a deliberate
contrast to the clean tas result. Also recolors the tas figures from
grey/amber to the Okabe-Ito black/blue/orange palette with distinct
markers per series, since the previous grey/amber pairing was hard to
tell apart for colorblind viewers.

Co-Authored-By: Claude Sonnet 5 <noreply@anthropic.com>
Claude-Session: https://claude.ai/code/session_01Xc9KT9bYsTuV3iYgcdNypu
</commit_message>
<xml_diff>
--- a/docs/bias_correction_slides/CMIP6_bias_correction_slides.pptx
+++ b/docs/bias_correction_slides/CMIP6_bias_correction_slides.pptx
@@ -10,6 +10,7 @@
     <p:sldId id="258" r:id="rId9"/>
     <p:sldId id="259" r:id="rId10"/>
     <p:sldId id="260" r:id="rId11"/>
+    <p:sldId id="261" r:id="rId12"/>
   </p:sldIdLst>
   <p:sldSz cx="12191695" cy="6858000" type="screen4x3"/>
   <p:notesSz cx="6858000" cy="9144000"/>
@@ -3326,7 +3327,7 @@
                 </a:solidFill>
                 <a:latin typeface="Arial"/>
               </a:rPr>
-              <a:t>1 / 5</a:t>
+              <a:t>1 / 6</a:t>
             </a:r>
           </a:p>
         </p:txBody>
@@ -5113,7 +5114,7 @@
                 </a:solidFill>
                 <a:latin typeface="Arial"/>
               </a:rPr>
-              <a:t>2 / 5</a:t>
+              <a:t>2 / 6</a:t>
             </a:r>
           </a:p>
         </p:txBody>
@@ -5355,7 +5356,7 @@
                 </a:solidFill>
                 <a:latin typeface="Arial"/>
               </a:rPr>
-              <a:t>3 / 5</a:t>
+              <a:t>3 / 6</a:t>
             </a:r>
           </a:p>
         </p:txBody>
@@ -5597,7 +5598,7 @@
                 </a:solidFill>
                 <a:latin typeface="Arial"/>
               </a:rPr>
-              <a:t>4 / 5</a:t>
+              <a:t>4 / 6</a:t>
             </a:r>
           </a:p>
         </p:txBody>
@@ -5635,6 +5636,248 @@
             <a:avLst/>
           </a:prstGeom>
           <a:solidFill>
+            <a:srgbClr val="F6F3EC"/>
+          </a:solidFill>
+          <a:ln>
+            <a:noFill/>
+          </a:ln>
+          <a:effectLst/>
+        </p:spPr>
+        <p:style>
+          <a:lnRef idx="1">
+            <a:schemeClr val="accent1"/>
+          </a:lnRef>
+          <a:fillRef idx="3">
+            <a:schemeClr val="accent1"/>
+          </a:fillRef>
+          <a:effectRef idx="2">
+            <a:schemeClr val="accent1"/>
+          </a:effectRef>
+          <a:fontRef idx="minor">
+            <a:schemeClr val="lt1"/>
+          </a:fontRef>
+        </p:style>
+        <p:txBody>
+          <a:bodyPr rtlCol="0" anchor="ctr"/>
+          <a:lstStyle/>
+          <a:p>
+            <a:pPr algn="ctr"/>
+          </a:p>
+        </p:txBody>
+      </p:sp>
+      <p:sp>
+        <p:nvSpPr>
+          <p:cNvPr id="3" name="TextBox 2"/>
+          <p:cNvSpPr txBox="1"/>
+          <p:nvPr/>
+        </p:nvSpPr>
+        <p:spPr>
+          <a:xfrm>
+            <a:off x="777240" y="777240"/>
+            <a:ext cx="10637215" cy="320040"/>
+          </a:xfrm>
+          <a:prstGeom prst="rect">
+            <a:avLst/>
+          </a:prstGeom>
+          <a:noFill/>
+        </p:spPr>
+        <p:txBody>
+          <a:bodyPr wrap="square" anchor="t" lIns="0" rIns="0" tIns="0" bIns="0">
+            <a:spAutoFit/>
+          </a:bodyPr>
+          <a:lstStyle/>
+          <a:p>
+            <a:pPr algn="l">
+              <a:lnSpc>
+                <a:spcPct val="100000"/>
+              </a:lnSpc>
+            </a:pPr>
+            <a:r>
+              <a:rPr sz="1300" b="1" i="0" spc="150">
+                <a:solidFill>
+                  <a:srgbClr val="C97A3E"/>
+                </a:solidFill>
+                <a:latin typeface="Arial"/>
+              </a:rPr>
+              <a:t>REAL EXAMPLE, A HARDER VARIABLE</a:t>
+            </a:r>
+          </a:p>
+        </p:txBody>
+      </p:sp>
+      <p:sp>
+        <p:nvSpPr>
+          <p:cNvPr id="4" name="TextBox 3"/>
+          <p:cNvSpPr txBox="1"/>
+          <p:nvPr/>
+        </p:nvSpPr>
+        <p:spPr>
+          <a:xfrm>
+            <a:off x="777240" y="1161288"/>
+            <a:ext cx="10637215" cy="640080"/>
+          </a:xfrm>
+          <a:prstGeom prst="rect">
+            <a:avLst/>
+          </a:prstGeom>
+          <a:noFill/>
+        </p:spPr>
+        <p:txBody>
+          <a:bodyPr wrap="square" anchor="t" lIns="0" rIns="0" tIns="0" bIns="0">
+            <a:spAutoFit/>
+          </a:bodyPr>
+          <a:lstStyle/>
+          <a:p>
+            <a:pPr algn="l">
+              <a:lnSpc>
+                <a:spcPct val="100000"/>
+              </a:lnSpc>
+            </a:pPr>
+            <a:r>
+              <a:rPr sz="2400" b="1" i="0">
+                <a:solidFill>
+                  <a:srgbClr val="1B2A33"/>
+                </a:solidFill>
+                <a:latin typeface="Georgia"/>
+              </a:rPr>
+              <a:t>Precipitation is not temperature — and this shows it, honestly</a:t>
+            </a:r>
+          </a:p>
+        </p:txBody>
+      </p:sp>
+      <p:pic>
+        <p:nvPicPr>
+          <p:cNvPr id="5" name="Picture 4" descr="pr_domain_example.png"/>
+          <p:cNvPicPr>
+            <a:picLocks noChangeAspect="1"/>
+          </p:cNvPicPr>
+          <p:nvPr/>
+        </p:nvPicPr>
+        <p:blipFill>
+          <a:blip r:embed="rId2"/>
+          <a:stretch>
+            <a:fillRect/>
+          </a:stretch>
+        </p:blipFill>
+        <p:spPr>
+          <a:xfrm>
+            <a:off x="2575407" y="1874520"/>
+            <a:ext cx="7040880" cy="3602683"/>
+          </a:xfrm>
+          <a:prstGeom prst="rect">
+            <a:avLst/>
+          </a:prstGeom>
+        </p:spPr>
+      </p:pic>
+      <p:sp>
+        <p:nvSpPr>
+          <p:cNvPr id="6" name="TextBox 5"/>
+          <p:cNvSpPr txBox="1"/>
+          <p:nvPr/>
+        </p:nvSpPr>
+        <p:spPr>
+          <a:xfrm>
+            <a:off x="777240" y="6291072"/>
+            <a:ext cx="8229600" cy="365760"/>
+          </a:xfrm>
+          <a:prstGeom prst="rect">
+            <a:avLst/>
+          </a:prstGeom>
+          <a:noFill/>
+        </p:spPr>
+        <p:txBody>
+          <a:bodyPr wrap="square" anchor="ctr" lIns="0" rIns="0" tIns="0" bIns="0">
+            <a:spAutoFit/>
+          </a:bodyPr>
+          <a:lstStyle/>
+          <a:p>
+            <a:pPr algn="l">
+              <a:lnSpc>
+                <a:spcPct val="100000"/>
+              </a:lnSpc>
+            </a:pPr>
+            <a:r>
+              <a:rPr sz="1300" b="0" i="0">
+                <a:solidFill>
+                  <a:srgbClr val="4B5A62"/>
+                </a:solidFill>
+                <a:latin typeface="Arial"/>
+              </a:rPr>
+              <a:t>GFDL-ESM4, historical, 2009–2014, domain mean — real production output</a:t>
+            </a:r>
+          </a:p>
+        </p:txBody>
+      </p:sp>
+      <p:sp>
+        <p:nvSpPr>
+          <p:cNvPr id="7" name="TextBox 6"/>
+          <p:cNvSpPr txBox="1"/>
+          <p:nvPr/>
+        </p:nvSpPr>
+        <p:spPr>
+          <a:xfrm>
+            <a:off x="9585655" y="6291072"/>
+            <a:ext cx="1828800" cy="365760"/>
+          </a:xfrm>
+          <a:prstGeom prst="rect">
+            <a:avLst/>
+          </a:prstGeom>
+          <a:noFill/>
+        </p:spPr>
+        <p:txBody>
+          <a:bodyPr wrap="square" anchor="ctr" lIns="0" rIns="0" tIns="0" bIns="0">
+            <a:spAutoFit/>
+          </a:bodyPr>
+          <a:lstStyle/>
+          <a:p>
+            <a:pPr algn="r">
+              <a:lnSpc>
+                <a:spcPct val="100000"/>
+              </a:lnSpc>
+            </a:pPr>
+            <a:r>
+              <a:rPr sz="1300" b="0" i="0">
+                <a:solidFill>
+                  <a:srgbClr val="4B5A62"/>
+                </a:solidFill>
+                <a:latin typeface="Arial"/>
+              </a:rPr>
+              <a:t>5 / 6</a:t>
+            </a:r>
+          </a:p>
+        </p:txBody>
+      </p:sp>
+    </p:spTree>
+  </p:cSld>
+  <p:clrMapOvr>
+    <a:masterClrMapping/>
+  </p:clrMapOvr>
+</p:sld>
+</file>
+
+<file path=ppt/slides/slide6.xml><?xml version="1.0" encoding="utf-8"?>
+<p:sld xmlns:a="http://schemas.openxmlformats.org/drawingml/2006/main" xmlns:p="http://schemas.openxmlformats.org/presentationml/2006/main" xmlns:r="http://schemas.openxmlformats.org/officeDocument/2006/relationships">
+  <p:cSld>
+    <p:spTree>
+      <p:nvGrpSpPr>
+        <p:cNvPr id="1" name=""/>
+        <p:cNvGrpSpPr/>
+        <p:nvPr/>
+      </p:nvGrpSpPr>
+      <p:grpSpPr/>
+      <p:sp>
+        <p:nvSpPr>
+          <p:cNvPr id="2" name="Rectangle 1"/>
+          <p:cNvSpPr/>
+          <p:nvPr/>
+        </p:nvSpPr>
+        <p:spPr>
+          <a:xfrm>
+            <a:off x="0" y="0"/>
+            <a:ext cx="12191695" cy="6858000"/>
+          </a:xfrm>
+          <a:prstGeom prst="rect">
+            <a:avLst/>
+          </a:prstGeom>
+          <a:solidFill>
             <a:srgbClr val="1B2A33"/>
           </a:solidFill>
           <a:ln>
@@ -6936,7 +7179,7 @@
                 </a:solidFill>
                 <a:latin typeface="Arial"/>
               </a:rPr>
-              <a:t>5 / 5</a:t>
+              <a:t>6 / 6</a:t>
             </a:r>
           </a:p>
         </p:txBody>

</xml_diff>

<commit_message>
Add binned-data inset to slide 3; correct evspsbl note's 3-model comparison
Slide 3 now shows an inset histogram of the actual January daily samples
feeding the quantile mapping at the example point -- which surfaced that
tas's ERA5 reference is never resampled to daily in production (only
net_sw/net_lw/evspsbl set resample:daily), so ref is hourly while hist/
future are daily for most meteo variables.

Also rewrites the evspsbl note's n_quantiles test section to replace an
earlier GFDL-only "October stands out" claim with a 3-model comparison
(GFDL-ESM4, CNRM-ESM2-1, MPI-ESM1-2-HR) showing the divergence is
model/year-specific, not tied to a particular calendar month.

Co-Authored-By: Claude Sonnet 5 <noreply@anthropic.com>
Claude-Session: https://claude.ai/code/session_01Xc9KT9bYsTuV3iYgcdNypu
</commit_message>
<xml_diff>
--- a/docs/bias_correction_slides/CMIP6_bias_correction_slides.pptx
+++ b/docs/bias_correction_slides/CMIP6_bias_correction_slides.pptx
@@ -5275,8 +5275,8 @@
         </p:blipFill>
         <p:spPr>
           <a:xfrm>
-            <a:off x="2163927" y="1938528"/>
-            <a:ext cx="7863840" cy="4356860"/>
+            <a:off x="2895447" y="1938528"/>
+            <a:ext cx="6400800" cy="4206348"/>
           </a:xfrm>
           <a:prstGeom prst="rect">
             <a:avLst/>

</xml_diff>